<commit_message>
Presentation: fix reading order, spacing and the annual-plan wording
From a fresh-eyes pass over every rendered slide:
- Reading order: an RLM after a Latin name keeps what follows on the
  Arabic side (sources row "36 ساعة", the POS row on the competitors
  slide); no "و" glued to a Latin word ("ورموز QR", the deploy line);
  no "$" inside Arabic text; numbers stay on the line with their unit.
- Annual plan on the go-to-market slide: 12 months for the price of 10,
  as on the plans slide (it said the reverse).
- Spacing: B2B moves into the header instead of sitting on the title;
  0.35" gaps on the plans, team, security and offline slides; the phone
  lines up with the screenshot; the backup divider is centred.

Co-Authored-By: Claude Opus 5.5 <noreply@anthropic.com>
Claude-Session: https://claude.ai/code/session_01PxRBM86R6tDR9cjQD8BWcs
</commit_message>
<xml_diff>
--- a/docs/presentation/menuPilot-pitch.pptx
+++ b/docs/presentation/menuPilot-pitch.pptx
@@ -123,7 +123,7 @@
   <p:extLst>
     <p:ext uri="{521415D9-36F7-43E2-AB2F-B90AF26B5E84}">
       <p14:sectionLst xmlns:p14="http://schemas.microsoft.com/office/powerpoint/2010/main">
-        <p14:section name="العرض (5 دقائق)" id="{c522ca72-8c82-5fd2-6e1d-42f832ef5fe6}">
+        <p14:section name="العرض (5 دقائق)" id="{3b87b6df-5d88-fd13-34b7-ce071822e53d}">
           <p14:sldIdLst>
             <p14:sldId id="256"/>
             <p14:sldId id="257"/>
@@ -137,7 +137,7 @@
             <p14:sldId id="265"/>
           </p14:sldIdLst>
         </p14:section>
-        <p14:section name="شرائح احتياطية" id="{c16b58cd-e37c-e2a4-8fac-8122b1c1a9b5}">
+        <p14:section name="شرائح احتياطية" id="{a24bb29f-5953-c181-92c8-936a604b3b8a}">
           <p14:sldIdLst>
             <p14:sldId id="266"/>
             <p14:sldId id="267"/>
@@ -2411,6 +2411,116 @@
 
 <file path=ppt/slideLayouts/slideLayout4.xml><?xml version="1.0" encoding="utf-8"?>
 <p:sldLayout xmlns:a="http://schemas.openxmlformats.org/drawingml/2006/main" xmlns:r="http://schemas.openxmlformats.org/officeDocument/2006/relationships" xmlns:p="http://schemas.openxmlformats.org/presentationml/2006/main" preserve="1">
+  <p:cSld name="DIVIDER">
+    <p:bg>
+      <p:bgPr>
+        <a:solidFill>
+          <a:schemeClr val="tx2"/>
+        </a:solidFill>
+      </p:bgPr>
+    </p:bg>
+    <p:spTree>
+      <p:nvGrpSpPr>
+        <p:cNvPr id="1" name=""/>
+        <p:cNvGrpSpPr/>
+        <p:nvPr/>
+      </p:nvGrpSpPr>
+      <p:grpSpPr>
+        <a:xfrm>
+          <a:off x="0" y="0"/>
+          <a:ext cx="0" cy="0"/>
+          <a:chOff x="0" y="0"/>
+          <a:chExt cx="0" cy="0"/>
+        </a:xfrm>
+      </p:grpSpPr>
+      <p:sp>
+        <p:nvSpPr>
+          <p:cNvPr id="2" name="Text 0"/>
+          <p:cNvSpPr/>
+          <p:nvPr>
+            <p:ph idx="100" type="body" hasCustomPrompt="1"/>
+          </p:nvPr>
+        </p:nvSpPr>
+        <p:spPr>
+          <a:xfrm>
+            <a:off x="5486400" y="2468880"/>
+            <a:ext cx="6156655" cy="411480"/>
+          </a:xfrm>
+          <a:prstGeom prst="rect">
+            <a:avLst/>
+          </a:prstGeom>
+          <a:noFill/>
+          <a:ln/>
+        </p:spPr>
+        <p:txBody>
+          <a:bodyPr wrap="square" rtlCol="0"/>
+          <a:lstStyle>
+            <a:lvl1pPr rtl="1" algn="r" indent="0" marL="0">
+              <a:buNone/>
+              <a:defRPr lang="en-US" sz="2000" b="1" dirty="0">
+                <a:solidFill>
+                  <a:schemeClr val="accent1"/>
+                </a:solidFill>
+              </a:defRPr>
+            </a:lvl1pPr>
+          </a:lstStyle>
+          <a:p>
+            <a:pPr algn="r" indent="0" marL="0">
+              <a:buNone/>
+            </a:pPr>
+            <a:endParaRPr lang="en-US" sz="2000" dirty="0"/>
+          </a:p>
+        </p:txBody>
+      </p:sp>
+      <p:sp>
+        <p:nvSpPr>
+          <p:cNvPr id="3" name="Text 0"/>
+          <p:cNvSpPr/>
+          <p:nvPr>
+            <p:ph idx="101" type="title" hasCustomPrompt="1"/>
+          </p:nvPr>
+        </p:nvSpPr>
+        <p:spPr>
+          <a:xfrm>
+            <a:off x="5486400" y="2926080"/>
+            <a:ext cx="6156655" cy="868680"/>
+          </a:xfrm>
+          <a:prstGeom prst="rect">
+            <a:avLst/>
+          </a:prstGeom>
+          <a:noFill/>
+          <a:ln/>
+        </p:spPr>
+        <p:txBody>
+          <a:bodyPr wrap="square" rtlCol="0"/>
+          <a:lstStyle>
+            <a:lvl1pPr rtl="1" algn="r" indent="0" marL="0">
+              <a:buNone/>
+              <a:defRPr lang="en-US" sz="4600" dirty="0">
+                <a:solidFill>
+                  <a:schemeClr val="bg2"/>
+                </a:solidFill>
+              </a:defRPr>
+            </a:lvl1pPr>
+          </a:lstStyle>
+          <a:p>
+            <a:pPr algn="r" indent="0" marL="0">
+              <a:buNone/>
+            </a:pPr>
+            <a:endParaRPr lang="en-US" sz="4600" dirty="0"/>
+          </a:p>
+        </p:txBody>
+      </p:sp>
+    </p:spTree>
+  </p:cSld>
+  <p:clrMapOvr>
+    <a:masterClrMapping/>
+  </p:clrMapOvr>
+</p:sldLayout>
+</file>
+
+<file path=ppt/slideLayouts/slideLayout5.xml><?xml version="1.0" encoding="utf-8"?>
+<p:sldLayout xmlns:a="http://schemas.openxmlformats.org/drawingml/2006/main" xmlns:r="http://schemas.openxmlformats.org/officeDocument/2006/relationships" xmlns:p="http://schemas.openxmlformats.org/presentationml/2006/main" preserve="1">
   <p:cSld name="STATEMENT">
     <p:bg>
       <p:bgPr>
@@ -2589,6 +2699,7 @@
     <p:sldLayoutId id="2147483650" r:id="rId2"/>
     <p:sldLayoutId id="2147483651" r:id="rId3"/>
     <p:sldLayoutId id="2147483652" r:id="rId4"/>
+    <p:sldLayoutId id="2147483653" r:id="rId5"/>
   </p:sldLayoutIdLst>
   <p:hf sldNum="0" hdr="0" ftr="0" dt="0"/>
   <p:txStyles>
@@ -3201,7 +3312,7 @@
         </p:nvSpPr>
         <p:spPr>
           <a:xfrm>
-            <a:off x="5486400" y="1737360"/>
+            <a:off x="5486400" y="2468880"/>
             <a:ext cx="6156655" cy="411480"/>
           </a:xfrm>
           <a:prstGeom prst="rect">
@@ -3239,8 +3350,8 @@
         </p:nvSpPr>
         <p:spPr>
           <a:xfrm>
-            <a:off x="5486400" y="2240280"/>
-            <a:ext cx="6156655" cy="2194560"/>
+            <a:off x="5486400" y="2926080"/>
+            <a:ext cx="6156655" cy="868680"/>
           </a:xfrm>
           <a:prstGeom prst="rect">
             <a:avLst/>
@@ -3275,7 +3386,7 @@
         </p:nvSpPr>
         <p:spPr>
           <a:xfrm>
-            <a:off x="5486400" y="3154680"/>
+            <a:off x="5486400" y="3840480"/>
             <a:ext cx="6156655" cy="457200"/>
           </a:xfrm>
           <a:prstGeom prst="rect">
@@ -3313,7 +3424,7 @@
         </p:nvSpPr>
         <p:spPr>
           <a:xfrm>
-            <a:off x="1920240" y="1600200"/>
+            <a:off x="1920240" y="2377440"/>
             <a:ext cx="2103120" cy="2103120"/>
           </a:xfrm>
           <a:prstGeom prst="roundRect">
@@ -3345,7 +3456,7 @@
         </p:blipFill>
         <p:spPr>
           <a:xfrm>
-            <a:off x="2424989" y="2104949"/>
+            <a:off x="2424989" y="2882189"/>
             <a:ext cx="1093622" cy="1093622"/>
           </a:xfrm>
           <a:prstGeom prst="rect">
@@ -3353,36 +3464,6 @@
           </a:prstGeom>
         </p:spPr>
       </p:pic>
-      <p:sp>
-        <p:nvSpPr>
-          <p:cNvPr id="8" name="Text 0"/>
-          <p:cNvSpPr/>
-          <p:nvPr>
-            <p:ph idx="102" type="body" hasCustomPrompt="1"/>
-          </p:nvPr>
-        </p:nvSpPr>
-        <p:spPr>
-          <a:xfrm>
-            <a:off x="5486400" y="4572000"/>
-            <a:ext cx="6156655" cy="822960"/>
-          </a:xfrm>
-          <a:prstGeom prst="rect">
-            <a:avLst/>
-          </a:prstGeom>
-          <a:noFill/>
-          <a:ln/>
-        </p:spPr>
-        <p:txBody>
-          <a:bodyPr wrap="square" lIns="0" tIns="0" rIns="0" bIns="0" rtlCol="0" anchor="t"/>
-          <a:lstStyle/>
-          <a:p>
-            <a:pPr algn="r" indent="0" marL="0">
-              <a:buNone/>
-            </a:pPr>
-            <a:endParaRPr lang="en-US" sz="2000" dirty="0"/>
-          </a:p>
-        </p:txBody>
-      </p:sp>
     </p:spTree>
   </p:cSld>
   <p:clrMapOvr>
@@ -3890,7 +3971,7 @@
                   <a:schemeClr val="tx2"/>
                 </a:solidFill>
               </a:rPr>
-              <a:t>إشارات لحظية عبر Laravel Reverb</a:t>
+              <a:t>إشارات لحظية عبر Laravel Reverb</a:t>
             </a:r>
             <a:endParaRPr lang="ar-SA" sz="1500" dirty="0"/>
           </a:p>
@@ -4072,7 +4153,7 @@
                   <a:schemeClr val="tx2"/>
                 </a:solidFill>
               </a:rPr>
-              <a:t>بيانات كل مطعم معزولة عن غيره</a:t>
+              <a:t>بيانات كل مطعم معزولة</a:t>
             </a:r>
             <a:endParaRPr lang="ar-SA" sz="1500" dirty="0"/>
           </a:p>
@@ -4090,7 +4171,7 @@
                   <a:schemeClr val="tx2"/>
                 </a:solidFill>
               </a:rPr>
-              <a:t>الصور في القاعدة، فلا تضيع عند النشر</a:t>
+              <a:t>الصور محفوظة في القاعدة</a:t>
             </a:r>
             <a:endParaRPr lang="ar-SA" sz="1500" dirty="0"/>
           </a:p>
@@ -4171,7 +4252,7 @@
                   <a:schemeClr val="tx2"/>
                 </a:solidFill>
               </a:rPr>
-              <a:t>النشر: Vercel للواجهة وRender للخادم · أكثر من 170 اختبارًا آليًا · فحص إنتاج من 30 نقطة بعد كل نشر (GO / NO-GO)</a:t>
+              <a:t>النشر: الواجهة على Vercel والخادم على Render · أكثر من 170 اختبارًا آليًا · فحص إنتاج من 30 نقطة بعد كل نشر (GO / NO-GO)</a:t>
             </a:r>
             <a:endParaRPr lang="ar-SA" sz="1600" dirty="0"/>
           </a:p>
@@ -4927,7 +5008,7 @@
         </p:nvSpPr>
         <p:spPr>
           <a:xfrm>
-            <a:off x="548640" y="5166360"/>
+            <a:off x="548640" y="5303520"/>
             <a:ext cx="11094415" cy="685800"/>
           </a:xfrm>
           <a:prstGeom prst="roundRect">
@@ -4954,7 +5035,7 @@
         </p:nvSpPr>
         <p:spPr>
           <a:xfrm>
-            <a:off x="868680" y="5166360"/>
+            <a:off x="868680" y="5303520"/>
             <a:ext cx="10454335" cy="685800"/>
           </a:xfrm>
           <a:prstGeom prst="rect">
@@ -5444,7 +5525,7 @@
         </p:nvSpPr>
         <p:spPr>
           <a:xfrm>
-            <a:off x="6255868" y="3703320"/>
+            <a:off x="6255868" y="3794760"/>
             <a:ext cx="5387188" cy="1691640"/>
           </a:xfrm>
           <a:prstGeom prst="roundRect">
@@ -5478,7 +5559,7 @@
         </p:nvSpPr>
         <p:spPr>
           <a:xfrm>
-            <a:off x="10765231" y="3995928"/>
+            <a:off x="10765231" y="4087368"/>
             <a:ext cx="585216" cy="585216"/>
           </a:xfrm>
           <a:prstGeom prst="roundRect">
@@ -5510,7 +5591,7 @@
         </p:blipFill>
         <p:spPr>
           <a:xfrm>
-            <a:off x="10905683" y="4136380"/>
+            <a:off x="10905683" y="4227820"/>
             <a:ext cx="304312" cy="304312"/>
           </a:xfrm>
           <a:prstGeom prst="rect">
@@ -5526,7 +5607,7 @@
         </p:nvSpPr>
         <p:spPr>
           <a:xfrm>
-            <a:off x="6548476" y="3977640"/>
+            <a:off x="6548476" y="4069080"/>
             <a:ext cx="4152748" cy="457200"/>
           </a:xfrm>
           <a:prstGeom prst="rect">
@@ -5562,7 +5643,7 @@
         </p:nvSpPr>
         <p:spPr>
           <a:xfrm>
-            <a:off x="6548476" y="4526280"/>
+            <a:off x="6548476" y="4617720"/>
             <a:ext cx="4152748" cy="731520"/>
           </a:xfrm>
           <a:prstGeom prst="rect">
@@ -5598,7 +5679,7 @@
         </p:nvSpPr>
         <p:spPr>
           <a:xfrm>
-            <a:off x="548640" y="3703320"/>
+            <a:off x="548640" y="3794760"/>
             <a:ext cx="5387188" cy="1691640"/>
           </a:xfrm>
           <a:prstGeom prst="roundRect">
@@ -5632,7 +5713,7 @@
         </p:nvSpPr>
         <p:spPr>
           <a:xfrm>
-            <a:off x="5058004" y="3995928"/>
+            <a:off x="5058004" y="4087368"/>
             <a:ext cx="585216" cy="585216"/>
           </a:xfrm>
           <a:prstGeom prst="roundRect">
@@ -5664,7 +5745,7 @@
         </p:blipFill>
         <p:spPr>
           <a:xfrm>
-            <a:off x="5198455" y="4136380"/>
+            <a:off x="5198455" y="4227820"/>
             <a:ext cx="304312" cy="304312"/>
           </a:xfrm>
           <a:prstGeom prst="rect">
@@ -5680,7 +5761,7 @@
         </p:nvSpPr>
         <p:spPr>
           <a:xfrm>
-            <a:off x="841248" y="3977640"/>
+            <a:off x="841248" y="4069080"/>
             <a:ext cx="4152748" cy="457200"/>
           </a:xfrm>
           <a:prstGeom prst="rect">
@@ -5716,7 +5797,7 @@
         </p:nvSpPr>
         <p:spPr>
           <a:xfrm>
-            <a:off x="841248" y="4526280"/>
+            <a:off x="841248" y="4617720"/>
             <a:ext cx="4152748" cy="731520"/>
           </a:xfrm>
           <a:prstGeom prst="rect">
@@ -5738,7 +5819,7 @@
                   <a:schemeClr val="tx2"/>
                 </a:solidFill>
               </a:rPr>
-              <a:t>بيانات كل مطعم معزولة، ومغطّاة باختبارات آلية</a:t>
+              <a:t>بيانات كل مطعم معزولة، ومغطّاة باختبارات</a:t>
             </a:r>
             <a:endParaRPr lang="ar-SA" sz="1700" dirty="0"/>
           </a:p>
@@ -7756,7 +7837,7 @@
                   <a:schemeClr val="tx2"/>
                 </a:solidFill>
               </a:rPr>
-              <a:t>شهري أو سنوي — والسنوي 10 أشهر بسعر 12</a:t>
+              <a:t>شهري أو سنوي — والسنوي 12 شهرًا بسعر 10</a:t>
             </a:r>
             <a:endParaRPr lang="ar-SA" sz="1700" dirty="0"/>
           </a:p>
@@ -8100,7 +8181,7 @@
                   <a:schemeClr val="accent3"/>
                 </a:solidFill>
               </a:rPr>
-              <a:t>  —  10 دقائق انتظار · 22% يغادرون · 38% يقلّلون البقشيش</a:t>
+              <a:t>‏  —  10 دقائق انتظار · 22% يغادرون · 38% يقلّلون البقشيش</a:t>
             </a:r>
             <a:endParaRPr lang="ar-SA" sz="1400" dirty="0"/>
           </a:p>
@@ -8239,7 +8320,7 @@
                   <a:schemeClr val="accent3"/>
                 </a:solidFill>
               </a:rPr>
-              <a:t>  —  36 ساعة انقطاع كامل للاتصالات في غزة</a:t>
+              <a:t>‏  —  36 ساعة انقطاع كامل للاتصالات في غزة</a:t>
             </a:r>
             <a:endParaRPr lang="ar-SA" sz="1400" dirty="0"/>
           </a:p>
@@ -8378,7 +8459,7 @@
                   <a:schemeClr val="accent3"/>
                 </a:solidFill>
               </a:rPr>
-              <a:t>  —  3,450 منشأة مطاعم وتقديم مشروبات دُمّرت في غزة</a:t>
+              <a:t>‏  —  3,450 منشأة مطاعم وتقديم مشروبات دُمّرت في غزة</a:t>
             </a:r>
             <a:endParaRPr lang="ar-SA" sz="1400" dirty="0"/>
           </a:p>
@@ -8517,7 +8598,7 @@
                   <a:schemeClr val="accent3"/>
                 </a:solidFill>
               </a:rPr>
-              <a:t>  —  نمو 19.4% سنويًا</a:t>
+              <a:t>‏  —  نمو 19.4% سنويًا</a:t>
             </a:r>
             <a:endParaRPr lang="ar-SA" sz="1400" dirty="0"/>
           </a:p>
@@ -8656,7 +8737,7 @@
                   <a:schemeClr val="accent3"/>
                 </a:solidFill>
               </a:rPr>
-              <a:t>  —  الطلب عبر QR بتكاملات · ~199 درهمًا شهريًا · عمولة 15–30%</a:t>
+              <a:t>‏  —  الطلب عبر QR بتكاملات · ~199 درهمًا شهريًا · عمولة 15–30%</a:t>
             </a:r>
             <a:endParaRPr lang="ar-SA" sz="1400" dirty="0"/>
           </a:p>
@@ -8795,7 +8876,7 @@
                   <a:schemeClr val="accent3"/>
                 </a:solidFill>
               </a:rPr>
-              <a:t>  —  أكثر من 170 اختبارًا · أكثر من 110 نقطة API · الأسعار</a:t>
+              <a:t>‏  —  أكثر من 170 اختبارًا · أكثر من 110 نقطة API · الأسعار</a:t>
             </a:r>
             <a:endParaRPr lang="ar-SA" sz="1400" dirty="0"/>
           </a:p>
@@ -11305,12 +11386,12 @@
         </p:nvSpPr>
         <p:spPr>
           <a:xfrm>
-            <a:off x="5193792" y="2039112"/>
-            <a:ext cx="1585747" cy="3282696"/>
+            <a:off x="5102352" y="2009394"/>
+            <a:ext cx="1522368" cy="3145536"/>
           </a:xfrm>
           <a:prstGeom prst="roundRect">
             <a:avLst>
-              <a:gd name="adj" fmla="val 12686"/>
+              <a:gd name="adj" fmla="val 13214"/>
             </a:avLst>
           </a:prstGeom>
           <a:solidFill>
@@ -11342,8 +11423,8 @@
         </p:blipFill>
         <p:spPr>
           <a:xfrm>
-            <a:off x="5257800" y="2103120"/>
-            <a:ext cx="1457731" cy="3154680"/>
+            <a:off x="5166360" y="2073402"/>
+            <a:ext cx="1394352" cy="3017520"/>
           </a:xfrm>
           <a:prstGeom prst="rect">
             <a:avLst/>
@@ -12314,7 +12395,7 @@
                   <a:schemeClr val="tx2"/>
                 </a:solidFill>
               </a:rPr>
-              <a:t>إيراد سنوي ممكن في غزة وحدها (3,450 مطعمًا × $29 × 12 شهرًا)</a:t>
+              <a:t>إيراد سنوي ممكن في غزة وحدها: 3,450 مطعمًا × 29 دولارًا × 12 شهرًا</a:t>
             </a:r>
             <a:endParaRPr lang="ar-SA" sz="1700" dirty="0"/>
           </a:p>
@@ -12696,7 +12777,7 @@
                   <a:schemeClr val="accent3"/>
                 </a:solidFill>
               </a:rPr>
-              <a:t>نموذج الربح</a:t>
+              <a:t>نموذج الربح · B2B للمطاعم والمقاهي</a:t>
             </a:r>
             <a:endParaRPr lang="ar-SA" sz="1600" dirty="0"/>
           </a:p>
@@ -12742,84 +12823,18 @@
       </p:sp>
       <p:sp>
         <p:nvSpPr>
-          <p:cNvPr id="4" name="b2b-badge"/>
+          <p:cNvPr id="4" name="plan-1"/>
           <p:cNvSpPr/>
           <p:nvPr/>
         </p:nvSpPr>
         <p:spPr>
           <a:xfrm>
-            <a:off x="548640" y="365760"/>
-            <a:ext cx="2514600" cy="402336"/>
+            <a:off x="8158277" y="1783080"/>
+            <a:ext cx="3484778" cy="2423160"/>
           </a:xfrm>
           <a:prstGeom prst="roundRect">
             <a:avLst>
-              <a:gd name="adj" fmla="val 50000"/>
-            </a:avLst>
-          </a:prstGeom>
-          <a:solidFill>
-            <a:schemeClr val="tx2"/>
-          </a:solidFill>
-          <a:ln/>
-        </p:spPr>
-      </p:sp>
-      <p:sp>
-        <p:nvSpPr>
-          <p:cNvPr id="5" name="b2b-label"/>
-          <p:cNvSpPr txBox="1"/>
-          <p:nvPr/>
-        </p:nvSpPr>
-        <p:spPr>
-          <a:xfrm>
-            <a:off x="548640" y="365760"/>
-            <a:ext cx="2514600" cy="402336"/>
-          </a:xfrm>
-          <a:prstGeom prst="rect">
-            <a:avLst/>
-          </a:prstGeom>
-          <a:noFill/>
-          <a:ln/>
-        </p:spPr>
-        <p:txBody>
-          <a:bodyPr wrap="square" lIns="0" tIns="0" rIns="0" bIns="0" rtlCol="0" anchor="ctr"/>
-          <a:lstStyle/>
-          <a:p>
-            <a:pPr rtl="1" algn="ctr" indent="0" marL="0">
-              <a:buNone/>
-            </a:pPr>
-            <a:r>
-              <a:rPr lang="ar-SA" altLang="en-US" sz="1500" b="1" dirty="0">
-                <a:solidFill>
-                  <a:schemeClr val="accent1"/>
-                </a:solidFill>
-              </a:rPr>
-              <a:t>B2B</a:t>
-            </a:r>
-            <a:r>
-              <a:rPr lang="ar-SA" altLang="en-US" sz="1500" dirty="0">
-                <a:solidFill>
-                  <a:schemeClr val="bg2"/>
-                </a:solidFill>
-              </a:rPr>
-              <a:t> · للمطاعم والمقاهي</a:t>
-            </a:r>
-            <a:endParaRPr lang="ar-SA" sz="1500" dirty="0"/>
-          </a:p>
-        </p:txBody>
-      </p:sp>
-      <p:sp>
-        <p:nvSpPr>
-          <p:cNvPr id="6" name="plan-1"/>
-          <p:cNvSpPr/>
-          <p:nvPr/>
-        </p:nvSpPr>
-        <p:spPr>
-          <a:xfrm>
-            <a:off x="8158277" y="1783080"/>
-            <a:ext cx="3484778" cy="2514600"/>
-          </a:xfrm>
-          <a:prstGeom prst="roundRect">
-            <a:avLst>
-              <a:gd name="adj" fmla="val 5818"/>
+              <a:gd name="adj" fmla="val 6038"/>
             </a:avLst>
           </a:prstGeom>
           <a:solidFill>
@@ -12842,7 +12857,7 @@
       </p:sp>
       <p:sp>
         <p:nvSpPr>
-          <p:cNvPr id="7" name="plan-name-1"/>
+          <p:cNvPr id="5" name="plan-name-1"/>
           <p:cNvSpPr txBox="1"/>
           <p:nvPr/>
         </p:nvSpPr>
@@ -12878,7 +12893,7 @@
       </p:sp>
       <p:sp>
         <p:nvSpPr>
-          <p:cNvPr id="8" name="plan-price-1"/>
+          <p:cNvPr id="6" name="plan-price-1"/>
           <p:cNvSpPr txBox="1"/>
           <p:nvPr/>
         </p:nvSpPr>
@@ -12922,7 +12937,7 @@
       </p:sp>
       <p:sp>
         <p:nvSpPr>
-          <p:cNvPr id="9" name="plan-body-1"/>
+          <p:cNvPr id="7" name="plan-body-1"/>
           <p:cNvSpPr txBox="1"/>
           <p:nvPr/>
         </p:nvSpPr>
@@ -12950,7 +12965,7 @@
                   <a:schemeClr val="tx2"/>
                 </a:solidFill>
               </a:rPr>
-              <a:t>منيو وطاولات وQR، مطبخ، نادل، كاشير، وفريق</a:t>
+              <a:t>منيو وطاولات ورموز QR، مطبخ، نادل، كاشير، وفريق</a:t>
             </a:r>
             <a:endParaRPr lang="ar-SA" sz="1600" dirty="0"/>
           </a:p>
@@ -12958,18 +12973,18 @@
       </p:sp>
       <p:sp>
         <p:nvSpPr>
-          <p:cNvPr id="10" name="plan-2"/>
+          <p:cNvPr id="8" name="plan-2"/>
           <p:cNvSpPr/>
           <p:nvPr/>
         </p:nvSpPr>
         <p:spPr>
           <a:xfrm>
             <a:off x="4353458" y="1783080"/>
-            <a:ext cx="3484778" cy="2514600"/>
+            <a:ext cx="3484778" cy="2423160"/>
           </a:xfrm>
           <a:prstGeom prst="roundRect">
             <a:avLst>
-              <a:gd name="adj" fmla="val 5818"/>
+              <a:gd name="adj" fmla="val 6038"/>
             </a:avLst>
           </a:prstGeom>
           <a:solidFill>
@@ -12987,7 +13002,7 @@
       </p:sp>
       <p:sp>
         <p:nvSpPr>
-          <p:cNvPr id="11" name="plan-popular-bg"/>
+          <p:cNvPr id="9" name="plan-popular-bg"/>
           <p:cNvSpPr/>
           <p:nvPr/>
         </p:nvSpPr>
@@ -13009,7 +13024,7 @@
       </p:sp>
       <p:sp>
         <p:nvSpPr>
-          <p:cNvPr id="12" name="plan-popular"/>
+          <p:cNvPr id="10" name="plan-popular"/>
           <p:cNvSpPr txBox="1"/>
           <p:nvPr/>
         </p:nvSpPr>
@@ -13045,7 +13060,7 @@
       </p:sp>
       <p:sp>
         <p:nvSpPr>
-          <p:cNvPr id="13" name="plan-name-2"/>
+          <p:cNvPr id="11" name="plan-name-2"/>
           <p:cNvSpPr txBox="1"/>
           <p:nvPr/>
         </p:nvSpPr>
@@ -13081,7 +13096,7 @@
       </p:sp>
       <p:sp>
         <p:nvSpPr>
-          <p:cNvPr id="14" name="plan-price-2"/>
+          <p:cNvPr id="12" name="plan-price-2"/>
           <p:cNvSpPr txBox="1"/>
           <p:nvPr/>
         </p:nvSpPr>
@@ -13125,7 +13140,7 @@
       </p:sp>
       <p:sp>
         <p:nvSpPr>
-          <p:cNvPr id="15" name="plan-body-2"/>
+          <p:cNvPr id="13" name="plan-body-2"/>
           <p:cNvSpPr txBox="1"/>
           <p:nvPr/>
         </p:nvSpPr>
@@ -13163,18 +13178,18 @@
       </p:sp>
       <p:sp>
         <p:nvSpPr>
-          <p:cNvPr id="16" name="plan-3"/>
+          <p:cNvPr id="14" name="plan-3"/>
           <p:cNvSpPr/>
           <p:nvPr/>
         </p:nvSpPr>
         <p:spPr>
           <a:xfrm>
             <a:off x="548640" y="1783080"/>
-            <a:ext cx="3484778" cy="2514600"/>
+            <a:ext cx="3484778" cy="2423160"/>
           </a:xfrm>
           <a:prstGeom prst="roundRect">
             <a:avLst>
-              <a:gd name="adj" fmla="val 5818"/>
+              <a:gd name="adj" fmla="val 6038"/>
             </a:avLst>
           </a:prstGeom>
           <a:solidFill>
@@ -13197,7 +13212,7 @@
       </p:sp>
       <p:sp>
         <p:nvSpPr>
-          <p:cNvPr id="17" name="plan-name-3"/>
+          <p:cNvPr id="15" name="plan-name-3"/>
           <p:cNvSpPr txBox="1"/>
           <p:nvPr/>
         </p:nvSpPr>
@@ -13233,7 +13248,7 @@
       </p:sp>
       <p:sp>
         <p:nvSpPr>
-          <p:cNvPr id="18" name="plan-price-3"/>
+          <p:cNvPr id="16" name="plan-price-3"/>
           <p:cNvSpPr txBox="1"/>
           <p:nvPr/>
         </p:nvSpPr>
@@ -13277,7 +13292,7 @@
       </p:sp>
       <p:sp>
         <p:nvSpPr>
-          <p:cNvPr id="19" name="plan-body-3"/>
+          <p:cNvPr id="17" name="plan-body-3"/>
           <p:cNvSpPr txBox="1"/>
           <p:nvPr/>
         </p:nvSpPr>
@@ -13313,7 +13328,7 @@
       </p:sp>
       <p:sp>
         <p:nvSpPr>
-          <p:cNvPr id="20" name="addon-1"/>
+          <p:cNvPr id="18" name="addon-1"/>
           <p:cNvSpPr/>
           <p:nvPr/>
         </p:nvSpPr>
@@ -13340,7 +13355,7 @@
       </p:sp>
       <p:pic>
         <p:nvPicPr>
-          <p:cNvPr id="21" name="addon-icon-1" descr="preencoded.png">    </p:cNvPr>
+          <p:cNvPr id="19" name="addon-icon-1" descr="preencoded.png">    </p:cNvPr>
           <p:cNvPicPr>
             <a:picLocks noChangeAspect="1"/>
           </p:cNvPicPr>
@@ -13364,7 +13379,7 @@
       </p:pic>
       <p:sp>
         <p:nvSpPr>
-          <p:cNvPr id="22" name="addon-label-1"/>
+          <p:cNvPr id="20" name="addon-label-1"/>
           <p:cNvSpPr txBox="1"/>
           <p:nvPr/>
         </p:nvSpPr>
@@ -13408,7 +13423,7 @@
       </p:sp>
       <p:sp>
         <p:nvSpPr>
-          <p:cNvPr id="23" name="addon-2"/>
+          <p:cNvPr id="21" name="addon-2"/>
           <p:cNvSpPr/>
           <p:nvPr/>
         </p:nvSpPr>
@@ -13435,7 +13450,7 @@
       </p:sp>
       <p:pic>
         <p:nvPicPr>
-          <p:cNvPr id="24" name="addon-icon-2" descr="preencoded.png">    </p:cNvPr>
+          <p:cNvPr id="22" name="addon-icon-2" descr="preencoded.png">    </p:cNvPr>
           <p:cNvPicPr>
             <a:picLocks noChangeAspect="1"/>
           </p:cNvPicPr>
@@ -13459,7 +13474,7 @@
       </p:pic>
       <p:sp>
         <p:nvSpPr>
-          <p:cNvPr id="25" name="addon-label-2"/>
+          <p:cNvPr id="23" name="addon-label-2"/>
           <p:cNvSpPr txBox="1"/>
           <p:nvPr/>
         </p:nvSpPr>
@@ -13503,7 +13518,7 @@
       </p:sp>
       <p:sp>
         <p:nvSpPr>
-          <p:cNvPr id="26" name="addon-3"/>
+          <p:cNvPr id="24" name="addon-3"/>
           <p:cNvSpPr/>
           <p:nvPr/>
         </p:nvSpPr>
@@ -13530,7 +13545,7 @@
       </p:sp>
       <p:pic>
         <p:nvPicPr>
-          <p:cNvPr id="27" name="addon-icon-3" descr="preencoded.png">    </p:cNvPr>
+          <p:cNvPr id="25" name="addon-icon-3" descr="preencoded.png">    </p:cNvPr>
           <p:cNvPicPr>
             <a:picLocks noChangeAspect="1"/>
           </p:cNvPicPr>
@@ -13554,7 +13569,7 @@
       </p:pic>
       <p:sp>
         <p:nvSpPr>
-          <p:cNvPr id="28" name="addon-label-3"/>
+          <p:cNvPr id="26" name="addon-label-3"/>
           <p:cNvSpPr txBox="1"/>
           <p:nvPr/>
         </p:nvSpPr>
@@ -13598,7 +13613,7 @@
       </p:sp>
       <p:sp>
         <p:nvSpPr>
-          <p:cNvPr id="29" name="bridge"/>
+          <p:cNvPr id="27" name="bridge"/>
           <p:cNvSpPr/>
           <p:nvPr/>
         </p:nvSpPr>
@@ -13622,7 +13637,7 @@
       </p:sp>
       <p:pic>
         <p:nvPicPr>
-          <p:cNvPr id="30" name="bridge-arrow" descr="preencoded.png">    </p:cNvPr>
+          <p:cNvPr id="28" name="bridge-arrow" descr="preencoded.png">    </p:cNvPr>
           <p:cNvPicPr>
             <a:picLocks noChangeAspect="1"/>
           </p:cNvPicPr>
@@ -13646,7 +13661,7 @@
       </p:pic>
       <p:sp>
         <p:nvSpPr>
-          <p:cNvPr id="31" name="bridge-text"/>
+          <p:cNvPr id="29" name="bridge-text"/>
           <p:cNvSpPr txBox="1"/>
           <p:nvPr/>
         </p:nvSpPr>
@@ -14065,7 +14080,7 @@
                   <a:schemeClr val="accent4"/>
                 </a:solidFill>
               </a:rPr>
-              <a:t>  ·  الحل الموجود اليوم</a:t>
+              <a:t>‏  ·  الحل الموجود اليوم</a:t>
             </a:r>
             <a:endParaRPr lang="ar-SA" sz="1700" dirty="0"/>
           </a:p>
@@ -14204,7 +14219,7 @@
                   <a:schemeClr val="accent4"/>
                 </a:solidFill>
               </a:rPr>
-              <a:t>  ·  رابط أو PDF</a:t>
+              <a:t>‏  ·  رابط أو PDF</a:t>
             </a:r>
             <a:endParaRPr lang="ar-SA" sz="1700" dirty="0"/>
           </a:p>
@@ -14343,7 +14358,7 @@
                   <a:schemeClr val="accent4"/>
                 </a:solidFill>
               </a:rPr>
-              <a:t>  ·  Foodics · Loyverse</a:t>
+              <a:t>‏  ·  Foodics · Loyverse</a:t>
             </a:r>
             <a:endParaRPr lang="ar-SA" sz="1700" dirty="0"/>
           </a:p>
@@ -14482,7 +14497,7 @@
                   <a:schemeClr val="accent4"/>
                 </a:solidFill>
               </a:rPr>
-              <a:t>  ·  طلبات Talabat</a:t>
+              <a:t>‏  ·  طلبات Talabat</a:t>
             </a:r>
             <a:endParaRPr lang="ar-SA" sz="1700" dirty="0"/>
           </a:p>
@@ -15122,12 +15137,12 @@
         </p:nvSpPr>
         <p:spPr>
           <a:xfrm>
-            <a:off x="9607052" y="1783080"/>
-            <a:ext cx="2036003" cy="3291840"/>
+            <a:off x="9680204" y="1783080"/>
+            <a:ext cx="1962851" cy="3291840"/>
           </a:xfrm>
           <a:prstGeom prst="roundRect">
             <a:avLst>
-              <a:gd name="adj" fmla="val 7186"/>
+              <a:gd name="adj" fmla="val 7454"/>
             </a:avLst>
           </a:prstGeom>
           <a:solidFill>
@@ -15158,7 +15173,7 @@
         </p:nvSpPr>
         <p:spPr>
           <a:xfrm>
-            <a:off x="10122134" y="2167128"/>
+            <a:off x="10158710" y="2167128"/>
             <a:ext cx="1005840" cy="1005840"/>
           </a:xfrm>
           <a:prstGeom prst="ellipse">
@@ -15178,7 +15193,7 @@
         </p:nvSpPr>
         <p:spPr>
           <a:xfrm>
-            <a:off x="10122134" y="2167128"/>
+            <a:off x="10158710" y="2167128"/>
             <a:ext cx="1005840" cy="1005840"/>
           </a:xfrm>
           <a:prstGeom prst="rect">
@@ -15214,8 +15229,8 @@
         </p:nvSpPr>
         <p:spPr>
           <a:xfrm>
-            <a:off x="9744212" y="3383280"/>
-            <a:ext cx="1761683" cy="731520"/>
+            <a:off x="9817364" y="3383280"/>
+            <a:ext cx="1688531" cy="731520"/>
           </a:xfrm>
           <a:prstGeom prst="rect">
             <a:avLst/>
@@ -15250,8 +15265,8 @@
         </p:nvSpPr>
         <p:spPr>
           <a:xfrm>
-            <a:off x="9744212" y="4160520"/>
-            <a:ext cx="1761683" cy="685800"/>
+            <a:off x="9817364" y="4160520"/>
+            <a:ext cx="1688531" cy="685800"/>
           </a:xfrm>
           <a:prstGeom prst="rect">
             <a:avLst/>
@@ -15286,12 +15301,12 @@
         </p:nvSpPr>
         <p:spPr>
           <a:xfrm>
-            <a:off x="7342449" y="1783080"/>
-            <a:ext cx="2036003" cy="3291840"/>
+            <a:off x="7397313" y="1783080"/>
+            <a:ext cx="1962851" cy="3291840"/>
           </a:xfrm>
           <a:prstGeom prst="roundRect">
             <a:avLst>
-              <a:gd name="adj" fmla="val 7186"/>
+              <a:gd name="adj" fmla="val 7454"/>
             </a:avLst>
           </a:prstGeom>
           <a:solidFill>
@@ -15320,7 +15335,7 @@
         </p:nvSpPr>
         <p:spPr>
           <a:xfrm>
-            <a:off x="7857531" y="2167128"/>
+            <a:off x="7875819" y="2167128"/>
             <a:ext cx="1005840" cy="1005840"/>
           </a:xfrm>
           <a:prstGeom prst="ellipse">
@@ -15340,7 +15355,7 @@
         </p:nvSpPr>
         <p:spPr>
           <a:xfrm>
-            <a:off x="7857531" y="2167128"/>
+            <a:off x="7875819" y="2167128"/>
             <a:ext cx="1005840" cy="1005840"/>
           </a:xfrm>
           <a:prstGeom prst="rect">
@@ -15376,8 +15391,8 @@
         </p:nvSpPr>
         <p:spPr>
           <a:xfrm>
-            <a:off x="7479609" y="3383280"/>
-            <a:ext cx="1761683" cy="731520"/>
+            <a:off x="7534473" y="3383280"/>
+            <a:ext cx="1688531" cy="731520"/>
           </a:xfrm>
           <a:prstGeom prst="rect">
             <a:avLst/>
@@ -15412,8 +15427,8 @@
         </p:nvSpPr>
         <p:spPr>
           <a:xfrm>
-            <a:off x="7479609" y="4160520"/>
-            <a:ext cx="1761683" cy="685800"/>
+            <a:off x="7534473" y="4160520"/>
+            <a:ext cx="1688531" cy="685800"/>
           </a:xfrm>
           <a:prstGeom prst="rect">
             <a:avLst/>
@@ -15448,12 +15463,12 @@
         </p:nvSpPr>
         <p:spPr>
           <a:xfrm>
-            <a:off x="5077846" y="1783080"/>
-            <a:ext cx="2036003" cy="3291840"/>
+            <a:off x="5114422" y="1783080"/>
+            <a:ext cx="1962851" cy="3291840"/>
           </a:xfrm>
           <a:prstGeom prst="roundRect">
             <a:avLst>
-              <a:gd name="adj" fmla="val 7186"/>
+              <a:gd name="adj" fmla="val 7454"/>
             </a:avLst>
           </a:prstGeom>
           <a:solidFill>
@@ -15538,8 +15553,8 @@
         </p:nvSpPr>
         <p:spPr>
           <a:xfrm>
-            <a:off x="5215006" y="3383280"/>
-            <a:ext cx="1761683" cy="731520"/>
+            <a:off x="5251582" y="3383280"/>
+            <a:ext cx="1688531" cy="731520"/>
           </a:xfrm>
           <a:prstGeom prst="rect">
             <a:avLst/>
@@ -15574,8 +15589,8 @@
         </p:nvSpPr>
         <p:spPr>
           <a:xfrm>
-            <a:off x="5215006" y="4160520"/>
-            <a:ext cx="1761683" cy="685800"/>
+            <a:off x="5251582" y="4160520"/>
+            <a:ext cx="1688531" cy="685800"/>
           </a:xfrm>
           <a:prstGeom prst="rect">
             <a:avLst/>
@@ -15610,12 +15625,12 @@
         </p:nvSpPr>
         <p:spPr>
           <a:xfrm>
-            <a:off x="2813243" y="1783080"/>
-            <a:ext cx="2036003" cy="3291840"/>
+            <a:off x="2831531" y="1783080"/>
+            <a:ext cx="1962851" cy="3291840"/>
           </a:xfrm>
           <a:prstGeom prst="roundRect">
             <a:avLst>
-              <a:gd name="adj" fmla="val 7186"/>
+              <a:gd name="adj" fmla="val 7454"/>
             </a:avLst>
           </a:prstGeom>
           <a:solidFill>
@@ -15644,7 +15659,7 @@
         </p:nvSpPr>
         <p:spPr>
           <a:xfrm>
-            <a:off x="3328325" y="2167128"/>
+            <a:off x="3310037" y="2167128"/>
             <a:ext cx="1005840" cy="1005840"/>
           </a:xfrm>
           <a:prstGeom prst="ellipse">
@@ -15664,7 +15679,7 @@
         </p:nvSpPr>
         <p:spPr>
           <a:xfrm>
-            <a:off x="3328325" y="2167128"/>
+            <a:off x="3310037" y="2167128"/>
             <a:ext cx="1005840" cy="1005840"/>
           </a:xfrm>
           <a:prstGeom prst="rect">
@@ -15700,8 +15715,8 @@
         </p:nvSpPr>
         <p:spPr>
           <a:xfrm>
-            <a:off x="2950403" y="3383280"/>
-            <a:ext cx="1761683" cy="731520"/>
+            <a:off x="2968691" y="3383280"/>
+            <a:ext cx="1688531" cy="731520"/>
           </a:xfrm>
           <a:prstGeom prst="rect">
             <a:avLst/>
@@ -15736,8 +15751,8 @@
         </p:nvSpPr>
         <p:spPr>
           <a:xfrm>
-            <a:off x="2950403" y="4160520"/>
-            <a:ext cx="1761683" cy="685800"/>
+            <a:off x="2968691" y="4160520"/>
+            <a:ext cx="1688531" cy="685800"/>
           </a:xfrm>
           <a:prstGeom prst="rect">
             <a:avLst/>
@@ -15773,11 +15788,11 @@
         <p:spPr>
           <a:xfrm>
             <a:off x="548640" y="1783080"/>
-            <a:ext cx="2036003" cy="3291840"/>
+            <a:ext cx="1962851" cy="3291840"/>
           </a:xfrm>
           <a:prstGeom prst="roundRect">
             <a:avLst>
-              <a:gd name="adj" fmla="val 7186"/>
+              <a:gd name="adj" fmla="val 7454"/>
             </a:avLst>
           </a:prstGeom>
           <a:solidFill>
@@ -15806,7 +15821,7 @@
         </p:nvSpPr>
         <p:spPr>
           <a:xfrm>
-            <a:off x="1063722" y="2167128"/>
+            <a:off x="1027146" y="2167128"/>
             <a:ext cx="1005840" cy="1005840"/>
           </a:xfrm>
           <a:prstGeom prst="ellipse">
@@ -15826,7 +15841,7 @@
         </p:nvSpPr>
         <p:spPr>
           <a:xfrm>
-            <a:off x="1063722" y="2167128"/>
+            <a:off x="1027146" y="2167128"/>
             <a:ext cx="1005840" cy="1005840"/>
           </a:xfrm>
           <a:prstGeom prst="rect">
@@ -15863,7 +15878,7 @@
         <p:spPr>
           <a:xfrm>
             <a:off x="685800" y="3383280"/>
-            <a:ext cx="1761683" cy="731520"/>
+            <a:ext cx="1688531" cy="731520"/>
           </a:xfrm>
           <a:prstGeom prst="rect">
             <a:avLst/>
@@ -15899,7 +15914,7 @@
         <p:spPr>
           <a:xfrm>
             <a:off x="685800" y="4160520"/>
-            <a:ext cx="1761683" cy="685800"/>
+            <a:ext cx="1688531" cy="685800"/>
           </a:xfrm>
           <a:prstGeom prst="rect">
             <a:avLst/>

</xml_diff>

<commit_message>
Team: Ali Abu Sweilem and Saja Saqallah, on the site and in the deck
The two names were wrong. Initials treat a family name ending in «الله»
as one word, so «سجى ساق الله» shows «س س» rather than «س ل».

Co-Authored-By: Claude Opus 5.5 <noreply@anthropic.com>
Claude-Session: https://claude.ai/code/session_01PxRBM86R6tDR9cjQD8BWcs
</commit_message>
<xml_diff>
--- a/docs/presentation/menuPilot-pitch.pptx
+++ b/docs/presentation/menuPilot-pitch.pptx
@@ -123,7 +123,7 @@
   <p:extLst>
     <p:ext uri="{521415D9-36F7-43E2-AB2F-B90AF26B5E84}">
       <p14:sectionLst xmlns:p14="http://schemas.microsoft.com/office/powerpoint/2010/main">
-        <p14:section name="العرض (5 دقائق)" id="{3b87b6df-5d88-fd13-34b7-ce071822e53d}">
+        <p14:section name="العرض (5 دقائق)" id="{c549372f-23d7-b5da-21d6-a7d532fa9b3d}">
           <p14:sldIdLst>
             <p14:sldId id="256"/>
             <p14:sldId id="257"/>
@@ -137,7 +137,7 @@
             <p14:sldId id="265"/>
           </p14:sldIdLst>
         </p14:section>
-        <p14:section name="شرائح احتياطية" id="{a24bb29f-5953-c181-92c8-936a604b3b8a}">
+        <p14:section name="شرائح احتياطية" id="{7e2b9354-5b83-84ed-33b2-d2be35868009}">
           <p14:sldIdLst>
             <p14:sldId id="266"/>
             <p14:sldId id="267"/>
@@ -15377,7 +15377,7 @@
                   <a:schemeClr val="bg2"/>
                 </a:solidFill>
               </a:rPr>
-              <a:t>ع ع</a:t>
+              <a:t>ع س</a:t>
             </a:r>
             <a:endParaRPr lang="ar-SA" sz="2200" dirty="0"/>
           </a:p>
@@ -15413,7 +15413,7 @@
                   <a:schemeClr val="tx1"/>
                 </a:solidFill>
               </a:rPr>
-              <a:t>علي عابد</a:t>
+              <a:t>علي أبو سويلم</a:t>
             </a:r>
             <a:endParaRPr lang="ar-SA" sz="1900" dirty="0"/>
           </a:p>
@@ -15737,7 +15737,7 @@
                   <a:schemeClr val="tx1"/>
                 </a:solidFill>
               </a:rPr>
-              <a:t>سجى سقالله</a:t>
+              <a:t>سجى ساق الله</a:t>
             </a:r>
             <a:endParaRPr lang="ar-SA" sz="1900" dirty="0"/>
           </a:p>

</xml_diff>